<commit_message>
Minor fixes to ariadne poster
</commit_message>
<xml_diff>
--- a/powerpoints/ariadne_poster.pptx
+++ b/powerpoints/ariadne_poster.pptx
@@ -2993,7 +2993,7 @@
         </p:blipFill>
         <p:spPr>
           <a:xfrm>
-            <a:off x="16294878" y="20345296"/>
+            <a:off x="16294878" y="20218296"/>
             <a:ext cx="12711823" cy="7150399"/>
           </a:xfrm>
           <a:prstGeom prst="rect">
@@ -3074,7 +3074,7 @@
         </p:blipFill>
         <p:spPr>
           <a:xfrm>
-            <a:off x="23463428" y="37739451"/>
+            <a:off x="23463428" y="37612451"/>
             <a:ext cx="1513757" cy="1672122"/>
           </a:xfrm>
           <a:prstGeom prst="rect">
@@ -3096,7 +3096,7 @@
         </p:nvSpPr>
         <p:spPr>
           <a:xfrm>
-            <a:off x="1572974" y="6603671"/>
+            <a:off x="1572974" y="6552871"/>
             <a:ext cx="3567195" cy="861774"/>
           </a:xfrm>
           <a:prstGeom prst="rect">
@@ -3135,7 +3135,7 @@
         </p:nvSpPr>
         <p:spPr>
           <a:xfrm>
-            <a:off x="1572973" y="7415341"/>
+            <a:off x="1572973" y="7364541"/>
             <a:ext cx="12977126" cy="2400657"/>
           </a:xfrm>
           <a:prstGeom prst="rect">
@@ -3171,8 +3171,8 @@
         </p:nvSpPr>
         <p:spPr>
           <a:xfrm>
-            <a:off x="-29113" y="40962937"/>
-            <a:ext cx="30304326" cy="1866634"/>
+            <a:off x="-29113" y="40638131"/>
+            <a:ext cx="30304326" cy="2191440"/>
           </a:xfrm>
           <a:prstGeom prst="rect">
             <a:avLst/>
@@ -3202,7 +3202,7 @@
           <a:lstStyle/>
           <a:p>
             <a:r>
-              <a:rPr lang="en-GB" sz="2400" b="0" i="0" dirty="0">
+              <a:rPr lang="en-GB" sz="2800" b="0" i="0" dirty="0">
                 <a:solidFill>
                   <a:schemeClr val="bg1"/>
                 </a:solidFill>
@@ -3214,7 +3214,7 @@
           </a:p>
           <a:p>
             <a:r>
-              <a:rPr lang="en-GB" sz="2400" dirty="0">
+              <a:rPr lang="en-GB" sz="2800" dirty="0">
                 <a:solidFill>
                   <a:schemeClr val="bg1"/>
                 </a:solidFill>
@@ -3223,18 +3223,18 @@
               <a:t>	1. </a:t>
             </a:r>
             <a:r>
-              <a:rPr lang="en-DE" sz="2400" dirty="0"/>
+              <a:rPr lang="en-DE" sz="2800" dirty="0"/>
               <a:t>Borman, T., Benedetti, G., Muluh, G., Raulo, A., Valderrama, B., Sannikov, A., ... &amp; Lahti, L. (2025). Orchestrating Microbiome Analysis with Bioconductor. </a:t>
             </a:r>
             <a:r>
-              <a:rPr lang="en-DE" sz="2400" i="1" dirty="0"/>
+              <a:rPr lang="en-DE" sz="2800" i="1" dirty="0"/>
               <a:t>bioRxiv</a:t>
             </a:r>
             <a:r>
-              <a:rPr lang="en-DE" sz="2400" dirty="0"/>
+              <a:rPr lang="en-DE" sz="2800" dirty="0"/>
               <a:t>. 10.1101/2025.10.29.685036.</a:t>
             </a:r>
-            <a:endParaRPr lang="en-GB" sz="2400" b="0" i="0" dirty="0">
+            <a:endParaRPr lang="en-GB" sz="2800" b="0" i="0" dirty="0">
               <a:solidFill>
                 <a:schemeClr val="bg1"/>
               </a:solidFill>
@@ -3244,7 +3244,7 @@
           </a:p>
           <a:p>
             <a:r>
-              <a:rPr lang="en-GB" sz="2400" b="0" i="0" dirty="0">
+              <a:rPr lang="en-GB" sz="2800" b="0" i="0" dirty="0">
                 <a:solidFill>
                   <a:schemeClr val="bg1"/>
                 </a:solidFill>
@@ -3253,34 +3253,34 @@
               <a:t>	2. </a:t>
             </a:r>
             <a:r>
-              <a:rPr lang="en-GB" sz="2400" dirty="0"/>
+              <a:rPr lang="en-GB" sz="2800" dirty="0"/>
               <a:t>Benedetti, G., </a:t>
             </a:r>
             <a:r>
-              <a:rPr lang="en-GB" sz="2400" dirty="0" err="1"/>
+              <a:rPr lang="en-GB" sz="2800" dirty="0" err="1"/>
               <a:t>Bastiaanssen</a:t>
             </a:r>
             <a:r>
-              <a:rPr lang="en-GB" sz="2400" dirty="0"/>
+              <a:rPr lang="en-GB" sz="2800" dirty="0"/>
               <a:t>, T., &amp; Lahti, L. (2026). </a:t>
             </a:r>
             <a:r>
-              <a:rPr lang="en-GB" sz="2400" dirty="0" err="1"/>
+              <a:rPr lang="en-GB" sz="2800" dirty="0" err="1"/>
               <a:t>ariadneDB</a:t>
             </a:r>
             <a:r>
-              <a:rPr lang="en-GB" sz="2400" dirty="0"/>
+              <a:rPr lang="en-GB" sz="2800" dirty="0"/>
               <a:t> [Data set]. </a:t>
             </a:r>
             <a:r>
-              <a:rPr lang="en-GB" sz="2400" i="1" dirty="0" err="1"/>
+              <a:rPr lang="en-GB" sz="2800" i="1" dirty="0" err="1"/>
               <a:t>Zenodo</a:t>
             </a:r>
             <a:r>
-              <a:rPr lang="en-GB" sz="2400" dirty="0"/>
+              <a:rPr lang="en-GB" sz="2800" dirty="0"/>
               <a:t>. 10.5281/zenodo.18788725.</a:t>
             </a:r>
-            <a:endParaRPr lang="en-GB" sz="2400" b="0" i="0" dirty="0">
+            <a:endParaRPr lang="en-GB" sz="2800" b="0" i="0" dirty="0">
               <a:solidFill>
                 <a:schemeClr val="bg1"/>
               </a:solidFill>
@@ -3289,7 +3289,7 @@
           </a:p>
           <a:p>
             <a:r>
-              <a:rPr lang="en-GB" sz="2400" dirty="0">
+              <a:rPr lang="en-GB" sz="2800" dirty="0">
                 <a:solidFill>
                   <a:schemeClr val="bg1"/>
                 </a:solidFill>
@@ -3298,34 +3298,34 @@
               <a:t>	3. </a:t>
             </a:r>
             <a:r>
-              <a:rPr lang="en-GB" sz="2400" dirty="0"/>
+              <a:rPr lang="en-GB" sz="2800" dirty="0"/>
               <a:t>Morgan M, Obenchain V, Hester J, </a:t>
             </a:r>
             <a:r>
-              <a:rPr lang="en-GB" sz="2400" dirty="0" err="1"/>
+              <a:rPr lang="en-GB" sz="2800" dirty="0" err="1"/>
               <a:t>Pagès</a:t>
             </a:r>
             <a:r>
-              <a:rPr lang="en-GB" sz="2400" dirty="0"/>
+              <a:rPr lang="en-GB" sz="2800" dirty="0"/>
               <a:t> H (2026). </a:t>
             </a:r>
             <a:r>
-              <a:rPr lang="en-GB" sz="2400" dirty="0" err="1"/>
+              <a:rPr lang="en-GB" sz="2800" dirty="0" err="1"/>
               <a:t>SummarizedExperiment</a:t>
             </a:r>
             <a:r>
-              <a:rPr lang="en-GB" sz="2400" dirty="0"/>
+              <a:rPr lang="en-GB" sz="2800" dirty="0"/>
               <a:t>: A container (S4 class) for matrix-like assays. </a:t>
             </a:r>
             <a:r>
-              <a:rPr lang="en-GB" sz="2400" i="1" dirty="0"/>
+              <a:rPr lang="en-GB" sz="2800" i="1" dirty="0"/>
               <a:t>Bioconductor</a:t>
             </a:r>
             <a:r>
-              <a:rPr lang="en-GB" sz="2400" dirty="0"/>
+              <a:rPr lang="en-GB" sz="2800" dirty="0"/>
               <a:t>. 10.18129/B9.bioc.SummarizedExperiment.</a:t>
             </a:r>
-            <a:endParaRPr lang="en-GB" sz="2400" dirty="0">
+            <a:endParaRPr lang="en-GB" sz="2800" dirty="0">
               <a:solidFill>
                 <a:schemeClr val="bg1"/>
               </a:solidFill>
@@ -3348,7 +3348,7 @@
         </p:nvSpPr>
         <p:spPr>
           <a:xfrm>
-            <a:off x="15725115" y="6608580"/>
+            <a:off x="15725115" y="6557780"/>
             <a:ext cx="7558087" cy="861774"/>
           </a:xfrm>
           <a:prstGeom prst="rect">
@@ -3387,7 +3387,7 @@
         </p:nvSpPr>
         <p:spPr>
           <a:xfrm>
-            <a:off x="1622272" y="13509085"/>
+            <a:off x="1622272" y="13458285"/>
             <a:ext cx="5467203" cy="861774"/>
           </a:xfrm>
           <a:prstGeom prst="rect">
@@ -3434,7 +3434,7 @@
         </p:blipFill>
         <p:spPr>
           <a:xfrm>
-            <a:off x="17635259" y="37712029"/>
+            <a:off x="17635259" y="37585029"/>
             <a:ext cx="1513757" cy="1658638"/>
           </a:xfrm>
           <a:prstGeom prst="rect">
@@ -3456,7 +3456,7 @@
         </p:nvSpPr>
         <p:spPr>
           <a:xfrm>
-            <a:off x="1569486" y="10868450"/>
+            <a:off x="1569486" y="10817650"/>
             <a:ext cx="12980613" cy="2400657"/>
           </a:xfrm>
           <a:prstGeom prst="rect">
@@ -3533,7 +3533,7 @@
         </p:nvSpPr>
         <p:spPr>
           <a:xfrm>
-            <a:off x="1572974" y="10056780"/>
+            <a:off x="1572974" y="10005980"/>
             <a:ext cx="3485249" cy="861774"/>
           </a:xfrm>
           <a:prstGeom prst="rect">
@@ -3572,7 +3572,7 @@
         </p:nvSpPr>
         <p:spPr>
           <a:xfrm>
-            <a:off x="15713041" y="13891263"/>
+            <a:off x="15713041" y="13840463"/>
             <a:ext cx="3157215" cy="309383"/>
           </a:xfrm>
           <a:prstGeom prst="rect">
@@ -3667,7 +3667,7 @@
         </p:blipFill>
         <p:spPr>
           <a:xfrm>
-            <a:off x="20560154" y="37722621"/>
+            <a:off x="20560154" y="37595621"/>
             <a:ext cx="1492136" cy="1631216"/>
           </a:xfrm>
           <a:prstGeom prst="rect">
@@ -3689,7 +3689,7 @@
         </p:nvSpPr>
         <p:spPr>
           <a:xfrm>
-            <a:off x="4392857" y="16759500"/>
+            <a:off x="4392857" y="16632500"/>
             <a:ext cx="7387150" cy="861774"/>
           </a:xfrm>
           <a:prstGeom prst="rect">
@@ -3728,7 +3728,7 @@
         </p:nvSpPr>
         <p:spPr>
           <a:xfrm>
-            <a:off x="17891254" y="16759500"/>
+            <a:off x="17891254" y="16632500"/>
             <a:ext cx="8693342" cy="861774"/>
           </a:xfrm>
           <a:prstGeom prst="rect">
@@ -3767,7 +3767,7 @@
         </p:nvSpPr>
         <p:spPr>
           <a:xfrm>
-            <a:off x="4910915" y="28953584"/>
+            <a:off x="4910915" y="28826584"/>
             <a:ext cx="6351034" cy="861774"/>
           </a:xfrm>
           <a:prstGeom prst="rect">
@@ -3806,7 +3806,7 @@
         </p:nvSpPr>
         <p:spPr>
           <a:xfrm>
-            <a:off x="18150959" y="28953584"/>
+            <a:off x="18150959" y="28826584"/>
             <a:ext cx="8070414" cy="861774"/>
           </a:xfrm>
           <a:prstGeom prst="rect">
@@ -3853,7 +3853,7 @@
         </p:blipFill>
         <p:spPr>
           <a:xfrm>
-            <a:off x="1382739" y="20124094"/>
+            <a:off x="1382739" y="19997094"/>
             <a:ext cx="13407386" cy="7541652"/>
           </a:xfrm>
           <a:prstGeom prst="rect">
@@ -3875,7 +3875,7 @@
         </p:nvSpPr>
         <p:spPr>
           <a:xfrm>
-            <a:off x="5108694" y="17772367"/>
+            <a:off x="5108694" y="17645367"/>
             <a:ext cx="5955476" cy="2400657"/>
           </a:xfrm>
           <a:prstGeom prst="rect">
@@ -3994,7 +3994,7 @@
         </p:nvSpPr>
         <p:spPr>
           <a:xfrm>
-            <a:off x="18631345" y="30000243"/>
+            <a:off x="18631345" y="29873243"/>
             <a:ext cx="7109639" cy="1015663"/>
           </a:xfrm>
           <a:prstGeom prst="rect">
@@ -4068,7 +4068,7 @@
         </p:nvSpPr>
         <p:spPr>
           <a:xfrm>
-            <a:off x="17130936" y="17772368"/>
+            <a:off x="17130936" y="17645368"/>
             <a:ext cx="10110460" cy="2400657"/>
           </a:xfrm>
           <a:prstGeom prst="rect">
@@ -4236,7 +4236,7 @@
         </p:nvSpPr>
         <p:spPr>
           <a:xfrm>
-            <a:off x="26095434" y="37872049"/>
+            <a:off x="26095434" y="37745049"/>
             <a:ext cx="1069524" cy="1631216"/>
           </a:xfrm>
           <a:prstGeom prst="rect">
@@ -4271,7 +4271,7 @@
         </p:nvSpPr>
         <p:spPr>
           <a:xfrm>
-            <a:off x="2196648" y="30000243"/>
+            <a:off x="2196648" y="29873243"/>
             <a:ext cx="11726287" cy="4247317"/>
           </a:xfrm>
           <a:prstGeom prst="rect">
@@ -4605,13 +4605,13 @@
           <p:nvPr>
             <p:extLst>
               <p:ext uri="{D42A27DB-BD31-4B8C-83A1-F6EECF244321}">
-                <p14:modId xmlns:p14="http://schemas.microsoft.com/office/powerpoint/2010/main" val="2573126565"/>
+                <p14:modId xmlns:p14="http://schemas.microsoft.com/office/powerpoint/2010/main" val="2022703913"/>
               </p:ext>
             </p:extLst>
           </p:nvPr>
         </p:nvGraphicFramePr>
         <p:xfrm>
-          <a:off x="5149989" y="35573223"/>
+          <a:off x="5149989" y="35446223"/>
           <a:ext cx="5819604" cy="3930042"/>
         </p:xfrm>
         <a:graphic>
@@ -4997,7 +4997,7 @@
         </p:nvSpPr>
         <p:spPr>
           <a:xfrm>
-            <a:off x="25943785" y="36614200"/>
+            <a:off x="25943785" y="36487200"/>
             <a:ext cx="1857368" cy="369332"/>
           </a:xfrm>
           <a:prstGeom prst="rect">
@@ -5032,7 +5032,7 @@
         </p:nvSpPr>
         <p:spPr>
           <a:xfrm>
-            <a:off x="15725114" y="7415341"/>
+            <a:off x="15725114" y="7364541"/>
             <a:ext cx="6327164" cy="3016210"/>
           </a:xfrm>
           <a:prstGeom prst="rect">
@@ -5145,7 +5145,7 @@
         </p:nvSpPr>
         <p:spPr>
           <a:xfrm>
-            <a:off x="22792682" y="8800640"/>
+            <a:off x="22792682" y="8749840"/>
             <a:ext cx="1746632" cy="553998"/>
           </a:xfrm>
           <a:prstGeom prst="rect">
@@ -5194,7 +5194,7 @@
         </p:nvSpPr>
         <p:spPr>
           <a:xfrm>
-            <a:off x="26363851" y="8800640"/>
+            <a:off x="26363851" y="8749840"/>
             <a:ext cx="1997663" cy="553998"/>
           </a:xfrm>
           <a:prstGeom prst="rect">
@@ -5243,7 +5243,7 @@
         </p:nvSpPr>
         <p:spPr>
           <a:xfrm>
-            <a:off x="24539313" y="10574078"/>
+            <a:off x="24539313" y="10523278"/>
             <a:ext cx="1824538" cy="553998"/>
           </a:xfrm>
           <a:prstGeom prst="rect">
@@ -5298,7 +5298,7 @@
         </p:nvSpPr>
         <p:spPr>
           <a:xfrm>
-            <a:off x="24766138" y="7739508"/>
+            <a:off x="24766138" y="7688708"/>
             <a:ext cx="1370888" cy="553998"/>
           </a:xfrm>
           <a:prstGeom prst="rect">
@@ -5350,7 +5350,7 @@
         </p:nvCxnSpPr>
         <p:spPr>
           <a:xfrm rot="5400000" flipH="1" flipV="1">
-            <a:off x="25159497" y="9369725"/>
+            <a:off x="25159497" y="9318925"/>
             <a:ext cx="1496439" cy="912269"/>
           </a:xfrm>
           <a:prstGeom prst="curvedConnector2">
@@ -5398,7 +5398,7 @@
         </p:nvCxnSpPr>
         <p:spPr>
           <a:xfrm rot="16200000" flipV="1">
-            <a:off x="24247229" y="9369725"/>
+            <a:off x="24247229" y="9318925"/>
             <a:ext cx="1496439" cy="912268"/>
           </a:xfrm>
           <a:prstGeom prst="curvedConnector2">
@@ -5446,7 +5446,7 @@
         </p:nvCxnSpPr>
         <p:spPr>
           <a:xfrm rot="5400000" flipH="1" flipV="1">
-            <a:off x="24311296" y="9433792"/>
+            <a:off x="24311296" y="9382992"/>
             <a:ext cx="2280572" cy="12700"/>
           </a:xfrm>
           <a:prstGeom prst="curvedConnector3">
@@ -5491,7 +5491,7 @@
         </p:nvSpPr>
         <p:spPr>
           <a:xfrm>
-            <a:off x="1626253" y="16569659"/>
+            <a:off x="1626253" y="16442659"/>
             <a:ext cx="12980613" cy="11075465"/>
           </a:xfrm>
           <a:prstGeom prst="rect">
@@ -5543,7 +5543,7 @@
         </p:nvSpPr>
         <p:spPr>
           <a:xfrm>
-            <a:off x="15725115" y="28762241"/>
+            <a:off x="15725115" y="28635241"/>
             <a:ext cx="12922103" cy="11348402"/>
           </a:xfrm>
           <a:prstGeom prst="rect">
@@ -5595,7 +5595,7 @@
         </p:nvSpPr>
         <p:spPr>
           <a:xfrm>
-            <a:off x="1565998" y="28768699"/>
+            <a:off x="1565998" y="28641699"/>
             <a:ext cx="13040868" cy="11324014"/>
           </a:xfrm>
           <a:prstGeom prst="rect">
@@ -5647,7 +5647,7 @@
         </p:nvSpPr>
         <p:spPr>
           <a:xfrm>
-            <a:off x="15725115" y="16565183"/>
+            <a:off x="15725115" y="16438183"/>
             <a:ext cx="12923845" cy="11079941"/>
           </a:xfrm>
           <a:prstGeom prst="rect">
@@ -5703,7 +5703,7 @@
         </p:nvCxnSpPr>
         <p:spPr>
           <a:xfrm rot="5400000">
-            <a:off x="14574948" y="21156608"/>
+            <a:off x="14574948" y="21029608"/>
             <a:ext cx="1123575" cy="14100606"/>
           </a:xfrm>
           <a:prstGeom prst="bentConnector3">
@@ -5713,7 +5713,8 @@
             <a:solidFill>
               <a:srgbClr val="FF0000"/>
             </a:solidFill>
-            <a:tailEnd type="triangle"/>
+            <a:headEnd type="none" w="med" len="med"/>
+            <a:tailEnd type="arrow" w="med" len="med"/>
           </a:ln>
         </p:spPr>
         <p:style>
@@ -5749,7 +5750,7 @@
         </p:nvCxnSpPr>
         <p:spPr>
           <a:xfrm flipV="1">
-            <a:off x="14606866" y="22105154"/>
+            <a:off x="14606866" y="21978154"/>
             <a:ext cx="1118249" cy="2238"/>
           </a:xfrm>
           <a:prstGeom prst="straightConnector1">
@@ -5759,7 +5760,8 @@
             <a:solidFill>
               <a:srgbClr val="FF0000"/>
             </a:solidFill>
-            <a:tailEnd type="triangle"/>
+            <a:headEnd type="none" w="med" len="med"/>
+            <a:tailEnd type="arrow" w="med" len="med"/>
           </a:ln>
         </p:spPr>
         <p:style>
@@ -5795,7 +5797,7 @@
         </p:nvCxnSpPr>
         <p:spPr>
           <a:xfrm>
-            <a:off x="14606866" y="34430706"/>
+            <a:off x="14606866" y="34303706"/>
             <a:ext cx="1118249" cy="5736"/>
           </a:xfrm>
           <a:prstGeom prst="straightConnector1">
@@ -5805,7 +5807,8 @@
             <a:solidFill>
               <a:srgbClr val="FF0000"/>
             </a:solidFill>
-            <a:tailEnd type="triangle"/>
+            <a:headEnd type="none" w="med" len="med"/>
+            <a:tailEnd type="arrow" w="med" len="med"/>
           </a:ln>
         </p:spPr>
         <p:style>
@@ -5838,13 +5841,13 @@
           <p:nvPr>
             <p:extLst>
               <p:ext uri="{D42A27DB-BD31-4B8C-83A1-F6EECF244321}">
-                <p14:modId xmlns:p14="http://schemas.microsoft.com/office/powerpoint/2010/main" val="3371987580"/>
+                <p14:modId xmlns:p14="http://schemas.microsoft.com/office/powerpoint/2010/main" val="708797518"/>
               </p:ext>
             </p:extLst>
           </p:nvPr>
         </p:nvGraphicFramePr>
         <p:xfrm>
-          <a:off x="17004159" y="11763991"/>
+          <a:off x="17004159" y="11713191"/>
           <a:ext cx="10364013" cy="3809710"/>
         </p:xfrm>
         <a:graphic>
@@ -6271,7 +6274,7 @@
         </p:nvSpPr>
         <p:spPr>
           <a:xfrm>
-            <a:off x="1565998" y="14323275"/>
+            <a:off x="1565998" y="14272475"/>
             <a:ext cx="12980613" cy="1477328"/>
           </a:xfrm>
           <a:prstGeom prst="rect">
@@ -6346,7 +6349,7 @@
         </p:blipFill>
         <p:spPr>
           <a:xfrm>
-            <a:off x="21102370" y="31668911"/>
+            <a:off x="21102370" y="31541911"/>
             <a:ext cx="6058508" cy="5165193"/>
           </a:xfrm>
           <a:prstGeom prst="rect">
@@ -6368,7 +6371,7 @@
         </p:nvSpPr>
         <p:spPr>
           <a:xfrm>
-            <a:off x="16191864" y="36807682"/>
+            <a:off x="16191864" y="36680682"/>
             <a:ext cx="3934923" cy="553998"/>
           </a:xfrm>
           <a:prstGeom prst="rect">
@@ -6403,7 +6406,7 @@
         </p:nvSpPr>
         <p:spPr>
           <a:xfrm>
-            <a:off x="2196648" y="34633392"/>
+            <a:off x="2196648" y="34506392"/>
             <a:ext cx="3950120" cy="553998"/>
           </a:xfrm>
           <a:prstGeom prst="rect">
@@ -6447,13 +6450,13 @@
           <p:nvPr>
             <p:extLst>
               <p:ext uri="{D42A27DB-BD31-4B8C-83A1-F6EECF244321}">
-                <p14:modId xmlns:p14="http://schemas.microsoft.com/office/powerpoint/2010/main" val="1044379754"/>
+                <p14:modId xmlns:p14="http://schemas.microsoft.com/office/powerpoint/2010/main" val="2379469713"/>
               </p:ext>
             </p:extLst>
           </p:nvPr>
         </p:nvGraphicFramePr>
         <p:xfrm>
-          <a:off x="17187750" y="33168570"/>
+          <a:off x="17187750" y="33041570"/>
           <a:ext cx="2112440" cy="2524272"/>
         </p:xfrm>
         <a:graphic>
@@ -6839,7 +6842,7 @@
         </p:nvSpPr>
         <p:spPr>
           <a:xfrm>
-            <a:off x="19949448" y="34008784"/>
+            <a:off x="19949448" y="33881784"/>
             <a:ext cx="503664" cy="861774"/>
           </a:xfrm>
           <a:prstGeom prst="rect">
@@ -6918,7 +6921,7 @@
         </p:blipFill>
         <p:spPr>
           <a:xfrm>
-            <a:off x="17910702" y="24308630"/>
+            <a:off x="17910702" y="24181630"/>
             <a:ext cx="1672122" cy="1672122"/>
           </a:xfrm>
           <a:prstGeom prst="rect">
@@ -6948,7 +6951,7 @@
         </p:blipFill>
         <p:spPr>
           <a:xfrm>
-            <a:off x="23446567" y="24875062"/>
+            <a:off x="23446567" y="24748062"/>
             <a:ext cx="1672337" cy="1672337"/>
           </a:xfrm>
           <a:prstGeom prst="rect">
@@ -6978,7 +6981,7 @@
         </p:blipFill>
         <p:spPr>
           <a:xfrm>
-            <a:off x="25071434" y="21178017"/>
+            <a:off x="25071434" y="21051017"/>
             <a:ext cx="2048000" cy="1469936"/>
           </a:xfrm>
           <a:prstGeom prst="rect">
@@ -7003,7 +7006,7 @@
         </p:nvCxnSpPr>
         <p:spPr>
           <a:xfrm flipV="1">
-            <a:off x="19582824" y="23458490"/>
+            <a:off x="19582824" y="23331490"/>
             <a:ext cx="569762" cy="1686201"/>
           </a:xfrm>
           <a:prstGeom prst="curvedConnector2">
@@ -7051,7 +7054,7 @@
         </p:nvCxnSpPr>
         <p:spPr>
           <a:xfrm rot="10800000">
-            <a:off x="22650791" y="23504973"/>
+            <a:off x="22650791" y="23377973"/>
             <a:ext cx="795777" cy="2206259"/>
           </a:xfrm>
           <a:prstGeom prst="curvedConnector2">
@@ -7099,7 +7102,7 @@
         </p:nvCxnSpPr>
         <p:spPr>
           <a:xfrm rot="10800000" flipV="1">
-            <a:off x="24539314" y="21912984"/>
+            <a:off x="24539314" y="21785984"/>
             <a:ext cx="532121" cy="1248823"/>
           </a:xfrm>
           <a:prstGeom prst="curvedConnector2">

</xml_diff>